<commit_message>
Site updated: 2023-06-21 02:42:39
</commit_message>
<xml_diff>
--- a/demo/sarcasm/jiaoben2304/first_page.pptx
+++ b/demo/sarcasm/jiaoben2304/first_page.pptx
@@ -5,11 +5,12 @@
     <p:sldMasterId id="2147483696" r:id="rId1"/>
   </p:sldMasterIdLst>
   <p:notesMasterIdLst>
-    <p:notesMasterId r:id="rId4"/>
+    <p:notesMasterId r:id="rId5"/>
   </p:notesMasterIdLst>
   <p:sldIdLst>
     <p:sldId id="256" r:id="rId2"/>
     <p:sldId id="257" r:id="rId3"/>
+    <p:sldId id="258" r:id="rId4"/>
   </p:sldIdLst>
   <p:sldSz cx="7199313" cy="9361488"/>
   <p:notesSz cx="6858000" cy="9144000"/>
@@ -624,6 +625,90 @@
     <p:extLst>
       <p:ext uri="{BB962C8B-B14F-4D97-AF65-F5344CB8AC3E}">
         <p14:creationId xmlns:p14="http://schemas.microsoft.com/office/powerpoint/2010/main" val="2788211362"/>
+      </p:ext>
+    </p:extLst>
+  </p:cSld>
+  <p:clrMapOvr>
+    <a:masterClrMapping/>
+  </p:clrMapOvr>
+</p:notes>
+</file>
+
+<file path=ppt/notesSlides/notesSlide3.xml><?xml version="1.0" encoding="utf-8"?>
+<p:notes xmlns:a="http://schemas.openxmlformats.org/drawingml/2006/main" xmlns:r="http://schemas.openxmlformats.org/officeDocument/2006/relationships" xmlns:p="http://schemas.openxmlformats.org/presentationml/2006/main">
+  <p:cSld>
+    <p:spTree>
+      <p:nvGrpSpPr>
+        <p:cNvPr id="1" name=""/>
+        <p:cNvGrpSpPr/>
+        <p:nvPr/>
+      </p:nvGrpSpPr>
+      <p:grpSpPr>
+        <a:xfrm>
+          <a:off x="0" y="0"/>
+          <a:ext cx="0" cy="0"/>
+          <a:chOff x="0" y="0"/>
+          <a:chExt cx="0" cy="0"/>
+        </a:xfrm>
+      </p:grpSpPr>
+      <p:sp>
+        <p:nvSpPr>
+          <p:cNvPr id="2" name="幻灯片图像占位符 1"/>
+          <p:cNvSpPr>
+            <a:spLocks noGrp="1" noRot="1" noChangeAspect="1"/>
+          </p:cNvSpPr>
+          <p:nvPr>
+            <p:ph type="sldImg"/>
+          </p:nvPr>
+        </p:nvSpPr>
+        <p:spPr/>
+      </p:sp>
+      <p:sp>
+        <p:nvSpPr>
+          <p:cNvPr id="3" name="备注占位符 2"/>
+          <p:cNvSpPr>
+            <a:spLocks noGrp="1"/>
+          </p:cNvSpPr>
+          <p:nvPr>
+            <p:ph type="body" idx="1"/>
+          </p:nvPr>
+        </p:nvSpPr>
+        <p:spPr/>
+        <p:txBody>
+          <a:bodyPr/>
+          <a:lstStyle/>
+          <a:p>
+            <a:endParaRPr lang="zh-CN" altLang="en-US" dirty="0"/>
+          </a:p>
+        </p:txBody>
+      </p:sp>
+      <p:sp>
+        <p:nvSpPr>
+          <p:cNvPr id="4" name="灯片编号占位符 3"/>
+          <p:cNvSpPr>
+            <a:spLocks noGrp="1"/>
+          </p:cNvSpPr>
+          <p:nvPr>
+            <p:ph type="sldNum" sz="quarter" idx="5"/>
+          </p:nvPr>
+        </p:nvSpPr>
+        <p:spPr/>
+        <p:txBody>
+          <a:bodyPr/>
+          <a:lstStyle/>
+          <a:p>
+            <a:fld id="{E51998DA-4F9D-40AD-B946-223C6F8A8A4E}" type="slidenum">
+              <a:rPr lang="zh-CN" altLang="en-US" smtClean="0"/>
+              <a:t>3</a:t>
+            </a:fld>
+            <a:endParaRPr lang="zh-CN" altLang="en-US"/>
+          </a:p>
+        </p:txBody>
+      </p:sp>
+    </p:spTree>
+    <p:extLst>
+      <p:ext uri="{BB962C8B-B14F-4D97-AF65-F5344CB8AC3E}">
+        <p14:creationId xmlns:p14="http://schemas.microsoft.com/office/powerpoint/2010/main" val="1763364219"/>
       </p:ext>
     </p:extLst>
   </p:cSld>
@@ -3659,6 +3744,97 @@
           </a:p>
         </p:txBody>
       </p:sp>
+      <p:sp>
+        <p:nvSpPr>
+          <p:cNvPr id="2" name="文本框 1">
+            <a:extLst>
+              <a:ext uri="{FF2B5EF4-FFF2-40B4-BE49-F238E27FC236}">
+                <a16:creationId xmlns:a16="http://schemas.microsoft.com/office/drawing/2014/main" id="{AB21E411-B6DF-AF73-F1C5-2D0702B9BBB3}"/>
+              </a:ext>
+            </a:extLst>
+          </p:cNvPr>
+          <p:cNvSpPr txBox="1"/>
+          <p:nvPr/>
+        </p:nvSpPr>
+        <p:spPr>
+          <a:xfrm>
+            <a:off x="5676901" y="8906368"/>
+            <a:ext cx="1225570" cy="369332"/>
+          </a:xfrm>
+          <a:prstGeom prst="rect">
+            <a:avLst/>
+          </a:prstGeom>
+          <a:noFill/>
+        </p:spPr>
+        <p:txBody>
+          <a:bodyPr wrap="square">
+            <a:spAutoFit/>
+          </a:bodyPr>
+          <a:lstStyle/>
+          <a:p>
+            <a:r>
+              <a:rPr lang="zh-CN" altLang="en-US" dirty="0">
+                <a:latin typeface="楷体" panose="02010609060101010101" pitchFamily="49" charset="-122"/>
+                <a:ea typeface="楷体" panose="02010609060101010101" pitchFamily="49" charset="-122"/>
+              </a:rPr>
+              <a:t>此处翻页</a:t>
+            </a:r>
+            <a:endParaRPr lang="zh-CN" altLang="en-US" dirty="0"/>
+          </a:p>
+        </p:txBody>
+      </p:sp>
+      <p:sp>
+        <p:nvSpPr>
+          <p:cNvPr id="6" name="箭头: 右 5">
+            <a:extLst>
+              <a:ext uri="{FF2B5EF4-FFF2-40B4-BE49-F238E27FC236}">
+                <a16:creationId xmlns:a16="http://schemas.microsoft.com/office/drawing/2014/main" id="{F164D18F-7E80-5FDF-3832-0414D5624C9E}"/>
+              </a:ext>
+            </a:extLst>
+          </p:cNvPr>
+          <p:cNvSpPr/>
+          <p:nvPr/>
+        </p:nvSpPr>
+        <p:spPr>
+          <a:xfrm>
+            <a:off x="6727397" y="9053002"/>
+            <a:ext cx="297656" cy="76064"/>
+          </a:xfrm>
+          <a:prstGeom prst="rightArrow">
+            <a:avLst>
+              <a:gd name="adj1" fmla="val 30534"/>
+              <a:gd name="adj2" fmla="val 144348"/>
+            </a:avLst>
+          </a:prstGeom>
+          <a:solidFill>
+            <a:schemeClr val="tx1"/>
+          </a:solidFill>
+        </p:spPr>
+        <p:style>
+          <a:lnRef idx="2">
+            <a:schemeClr val="accent1">
+              <a:shade val="15000"/>
+            </a:schemeClr>
+          </a:lnRef>
+          <a:fillRef idx="1">
+            <a:schemeClr val="accent1"/>
+          </a:fillRef>
+          <a:effectRef idx="0">
+            <a:schemeClr val="accent1"/>
+          </a:effectRef>
+          <a:fontRef idx="minor">
+            <a:schemeClr val="lt1"/>
+          </a:fontRef>
+        </p:style>
+        <p:txBody>
+          <a:bodyPr rtlCol="0" anchor="ctr"/>
+          <a:lstStyle/>
+          <a:p>
+            <a:pPr algn="ctr"/>
+            <a:endParaRPr lang="zh-CN" altLang="en-US"/>
+          </a:p>
+        </p:txBody>
+      </p:sp>
     </p:spTree>
     <p:extLst>
       <p:ext uri="{BB962C8B-B14F-4D97-AF65-F5344CB8AC3E}">
@@ -3758,6 +3934,166 @@
     <p:extLst>
       <p:ext uri="{BB962C8B-B14F-4D97-AF65-F5344CB8AC3E}">
         <p14:creationId xmlns:p14="http://schemas.microsoft.com/office/powerpoint/2010/main" val="3657221737"/>
+      </p:ext>
+    </p:extLst>
+  </p:cSld>
+  <p:clrMapOvr>
+    <a:masterClrMapping/>
+  </p:clrMapOvr>
+</p:sld>
+</file>
+
+<file path=ppt/slides/slide3.xml><?xml version="1.0" encoding="utf-8"?>
+<p:sld xmlns:a="http://schemas.openxmlformats.org/drawingml/2006/main" xmlns:r="http://schemas.openxmlformats.org/officeDocument/2006/relationships" xmlns:p="http://schemas.openxmlformats.org/presentationml/2006/main">
+  <p:cSld>
+    <p:spTree>
+      <p:nvGrpSpPr>
+        <p:cNvPr id="1" name=""/>
+        <p:cNvGrpSpPr/>
+        <p:nvPr/>
+      </p:nvGrpSpPr>
+      <p:grpSpPr>
+        <a:xfrm>
+          <a:off x="0" y="0"/>
+          <a:ext cx="0" cy="0"/>
+          <a:chOff x="0" y="0"/>
+          <a:chExt cx="0" cy="0"/>
+        </a:xfrm>
+      </p:grpSpPr>
+      <p:sp>
+        <p:nvSpPr>
+          <p:cNvPr id="2" name="矩形 1">
+            <a:extLst>
+              <a:ext uri="{FF2B5EF4-FFF2-40B4-BE49-F238E27FC236}">
+                <a16:creationId xmlns:a16="http://schemas.microsoft.com/office/drawing/2014/main" id="{EF6926FA-17B3-3F3A-2480-88B1352F0803}"/>
+              </a:ext>
+            </a:extLst>
+          </p:cNvPr>
+          <p:cNvSpPr/>
+          <p:nvPr/>
+        </p:nvSpPr>
+        <p:spPr>
+          <a:xfrm>
+            <a:off x="411480" y="2590800"/>
+            <a:ext cx="579120" cy="464820"/>
+          </a:xfrm>
+          <a:prstGeom prst="rect">
+            <a:avLst/>
+          </a:prstGeom>
+          <a:noFill/>
+          <a:ln w="57150">
+            <a:solidFill>
+              <a:schemeClr val="tx1"/>
+            </a:solidFill>
+          </a:ln>
+        </p:spPr>
+        <p:style>
+          <a:lnRef idx="2">
+            <a:schemeClr val="accent1">
+              <a:shade val="15000"/>
+            </a:schemeClr>
+          </a:lnRef>
+          <a:fillRef idx="1">
+            <a:schemeClr val="accent1"/>
+          </a:fillRef>
+          <a:effectRef idx="0">
+            <a:schemeClr val="accent1"/>
+          </a:effectRef>
+          <a:fontRef idx="minor">
+            <a:schemeClr val="lt1"/>
+          </a:fontRef>
+        </p:style>
+        <p:txBody>
+          <a:bodyPr rtlCol="0" anchor="ctr"/>
+          <a:lstStyle/>
+          <a:p>
+            <a:pPr algn="ctr"/>
+            <a:endParaRPr lang="zh-CN" altLang="en-US"/>
+          </a:p>
+        </p:txBody>
+      </p:sp>
+      <p:cxnSp>
+        <p:nvCxnSpPr>
+          <p:cNvPr id="4" name="直接连接符 3">
+            <a:extLst>
+              <a:ext uri="{FF2B5EF4-FFF2-40B4-BE49-F238E27FC236}">
+                <a16:creationId xmlns:a16="http://schemas.microsoft.com/office/drawing/2014/main" id="{622C7C84-08CF-F42E-62C6-38B6AF41EEC0}"/>
+              </a:ext>
+            </a:extLst>
+          </p:cNvPr>
+          <p:cNvCxnSpPr>
+            <a:cxnSpLocks/>
+          </p:cNvCxnSpPr>
+          <p:nvPr/>
+        </p:nvCxnSpPr>
+        <p:spPr>
+          <a:xfrm>
+            <a:off x="1120457" y="2555081"/>
+            <a:ext cx="0" cy="533400"/>
+          </a:xfrm>
+          <a:prstGeom prst="line">
+            <a:avLst/>
+          </a:prstGeom>
+          <a:ln w="57150"/>
+        </p:spPr>
+        <p:style>
+          <a:lnRef idx="1">
+            <a:schemeClr val="dk1"/>
+          </a:lnRef>
+          <a:fillRef idx="0">
+            <a:schemeClr val="dk1"/>
+          </a:fillRef>
+          <a:effectRef idx="0">
+            <a:schemeClr val="dk1"/>
+          </a:effectRef>
+          <a:fontRef idx="minor">
+            <a:schemeClr val="tx1"/>
+          </a:fontRef>
+        </p:style>
+      </p:cxnSp>
+      <p:cxnSp>
+        <p:nvCxnSpPr>
+          <p:cNvPr id="10" name="直接连接符 9">
+            <a:extLst>
+              <a:ext uri="{FF2B5EF4-FFF2-40B4-BE49-F238E27FC236}">
+                <a16:creationId xmlns:a16="http://schemas.microsoft.com/office/drawing/2014/main" id="{CF0C09C9-83E9-A6E5-BF4F-F17AF0D6F57E}"/>
+              </a:ext>
+            </a:extLst>
+          </p:cNvPr>
+          <p:cNvCxnSpPr>
+            <a:cxnSpLocks/>
+          </p:cNvCxnSpPr>
+          <p:nvPr/>
+        </p:nvCxnSpPr>
+        <p:spPr>
+          <a:xfrm>
+            <a:off x="1229994" y="2555081"/>
+            <a:ext cx="0" cy="533400"/>
+          </a:xfrm>
+          <a:prstGeom prst="line">
+            <a:avLst/>
+          </a:prstGeom>
+          <a:ln w="57150"/>
+        </p:spPr>
+        <p:style>
+          <a:lnRef idx="1">
+            <a:schemeClr val="dk1"/>
+          </a:lnRef>
+          <a:fillRef idx="0">
+            <a:schemeClr val="dk1"/>
+          </a:fillRef>
+          <a:effectRef idx="0">
+            <a:schemeClr val="dk1"/>
+          </a:effectRef>
+          <a:fontRef idx="minor">
+            <a:schemeClr val="tx1"/>
+          </a:fontRef>
+        </p:style>
+      </p:cxnSp>
+    </p:spTree>
+    <p:extLst>
+      <p:ext uri="{BB962C8B-B14F-4D97-AF65-F5344CB8AC3E}">
+        <p14:creationId xmlns:p14="http://schemas.microsoft.com/office/powerpoint/2010/main" val="1238362041"/>
       </p:ext>
     </p:extLst>
   </p:cSld>

</xml_diff>

<commit_message>
Site updated: 2023-06-24 00:44:29
</commit_message>
<xml_diff>
--- a/demo/sarcasm/jiaoben2304/first_page.pptx
+++ b/demo/sarcasm/jiaoben2304/first_page.pptx
@@ -199,7 +199,7 @@
           <a:p>
             <a:fld id="{9F2C887D-13CF-45CF-8BA1-CEA69189E219}" type="datetimeFigureOut">
               <a:rPr lang="zh-CN" altLang="en-US" smtClean="0"/>
-              <a:t>2023/6/20</a:t>
+              <a:t>2023/6/23</a:t>
             </a:fld>
             <a:endParaRPr lang="zh-CN" altLang="en-US"/>
           </a:p>
@@ -849,7 +849,7 @@
           <a:p>
             <a:fld id="{7F066AC1-9EBE-4FAC-AB84-7C4667A0BEE3}" type="datetimeFigureOut">
               <a:rPr lang="zh-CN" altLang="en-US" smtClean="0"/>
-              <a:t>2023/6/20</a:t>
+              <a:t>2023/6/23</a:t>
             </a:fld>
             <a:endParaRPr lang="zh-CN" altLang="en-US"/>
           </a:p>
@@ -1019,7 +1019,7 @@
           <a:p>
             <a:fld id="{7F066AC1-9EBE-4FAC-AB84-7C4667A0BEE3}" type="datetimeFigureOut">
               <a:rPr lang="zh-CN" altLang="en-US" smtClean="0"/>
-              <a:t>2023/6/20</a:t>
+              <a:t>2023/6/23</a:t>
             </a:fld>
             <a:endParaRPr lang="zh-CN" altLang="en-US"/>
           </a:p>
@@ -1199,7 +1199,7 @@
           <a:p>
             <a:fld id="{7F066AC1-9EBE-4FAC-AB84-7C4667A0BEE3}" type="datetimeFigureOut">
               <a:rPr lang="zh-CN" altLang="en-US" smtClean="0"/>
-              <a:t>2023/6/20</a:t>
+              <a:t>2023/6/23</a:t>
             </a:fld>
             <a:endParaRPr lang="zh-CN" altLang="en-US"/>
           </a:p>
@@ -1369,7 +1369,7 @@
           <a:p>
             <a:fld id="{7F066AC1-9EBE-4FAC-AB84-7C4667A0BEE3}" type="datetimeFigureOut">
               <a:rPr lang="zh-CN" altLang="en-US" smtClean="0"/>
-              <a:t>2023/6/20</a:t>
+              <a:t>2023/6/23</a:t>
             </a:fld>
             <a:endParaRPr lang="zh-CN" altLang="en-US"/>
           </a:p>
@@ -1613,7 +1613,7 @@
           <a:p>
             <a:fld id="{7F066AC1-9EBE-4FAC-AB84-7C4667A0BEE3}" type="datetimeFigureOut">
               <a:rPr lang="zh-CN" altLang="en-US" smtClean="0"/>
-              <a:t>2023/6/20</a:t>
+              <a:t>2023/6/23</a:t>
             </a:fld>
             <a:endParaRPr lang="zh-CN" altLang="en-US"/>
           </a:p>
@@ -1845,7 +1845,7 @@
           <a:p>
             <a:fld id="{7F066AC1-9EBE-4FAC-AB84-7C4667A0BEE3}" type="datetimeFigureOut">
               <a:rPr lang="zh-CN" altLang="en-US" smtClean="0"/>
-              <a:t>2023/6/20</a:t>
+              <a:t>2023/6/23</a:t>
             </a:fld>
             <a:endParaRPr lang="zh-CN" altLang="en-US"/>
           </a:p>
@@ -2212,7 +2212,7 @@
           <a:p>
             <a:fld id="{7F066AC1-9EBE-4FAC-AB84-7C4667A0BEE3}" type="datetimeFigureOut">
               <a:rPr lang="zh-CN" altLang="en-US" smtClean="0"/>
-              <a:t>2023/6/20</a:t>
+              <a:t>2023/6/23</a:t>
             </a:fld>
             <a:endParaRPr lang="zh-CN" altLang="en-US"/>
           </a:p>
@@ -2330,7 +2330,7 @@
           <a:p>
             <a:fld id="{7F066AC1-9EBE-4FAC-AB84-7C4667A0BEE3}" type="datetimeFigureOut">
               <a:rPr lang="zh-CN" altLang="en-US" smtClean="0"/>
-              <a:t>2023/6/20</a:t>
+              <a:t>2023/6/23</a:t>
             </a:fld>
             <a:endParaRPr lang="zh-CN" altLang="en-US"/>
           </a:p>
@@ -2425,7 +2425,7 @@
           <a:p>
             <a:fld id="{7F066AC1-9EBE-4FAC-AB84-7C4667A0BEE3}" type="datetimeFigureOut">
               <a:rPr lang="zh-CN" altLang="en-US" smtClean="0"/>
-              <a:t>2023/6/20</a:t>
+              <a:t>2023/6/23</a:t>
             </a:fld>
             <a:endParaRPr lang="zh-CN" altLang="en-US"/>
           </a:p>
@@ -2702,7 +2702,7 @@
           <a:p>
             <a:fld id="{7F066AC1-9EBE-4FAC-AB84-7C4667A0BEE3}" type="datetimeFigureOut">
               <a:rPr lang="zh-CN" altLang="en-US" smtClean="0"/>
-              <a:t>2023/6/20</a:t>
+              <a:t>2023/6/23</a:t>
             </a:fld>
             <a:endParaRPr lang="zh-CN" altLang="en-US"/>
           </a:p>
@@ -2959,7 +2959,7 @@
           <a:p>
             <a:fld id="{7F066AC1-9EBE-4FAC-AB84-7C4667A0BEE3}" type="datetimeFigureOut">
               <a:rPr lang="zh-CN" altLang="en-US" smtClean="0"/>
-              <a:t>2023/6/20</a:t>
+              <a:t>2023/6/23</a:t>
             </a:fld>
             <a:endParaRPr lang="zh-CN" altLang="en-US"/>
           </a:p>
@@ -3172,7 +3172,7 @@
           <a:p>
             <a:fld id="{7F066AC1-9EBE-4FAC-AB84-7C4667A0BEE3}" type="datetimeFigureOut">
               <a:rPr lang="zh-CN" altLang="en-US" smtClean="0"/>
-              <a:t>2023/6/20</a:t>
+              <a:t>2023/6/23</a:t>
             </a:fld>
             <a:endParaRPr lang="zh-CN" altLang="en-US"/>
           </a:p>
@@ -3627,8 +3627,8 @@
         </p:nvSpPr>
         <p:spPr>
           <a:xfrm>
-            <a:off x="115449" y="1068450"/>
-            <a:ext cx="5296394" cy="754053"/>
+            <a:off x="115449" y="795321"/>
+            <a:ext cx="5296394" cy="1446550"/>
           </a:xfrm>
           <a:prstGeom prst="rect">
             <a:avLst/>
@@ -3641,16 +3641,22 @@
           </a:bodyPr>
           <a:lstStyle/>
           <a:p>
-            <a:r>
-              <a:rPr lang="zh-CN" altLang="en-US" sz="4300" dirty="0">
-                <a:latin typeface="楷体" panose="02010609060101010101" pitchFamily="49" charset="-122"/>
-                <a:ea typeface="楷体" panose="02010609060101010101" pitchFamily="49" charset="-122"/>
+            <a:pPr algn="ctr"/>
+            <a:r>
+              <a:rPr lang="en-US" altLang="zh-CN" sz="4400" b="0" i="0" dirty="0">
+                <a:solidFill>
+                  <a:srgbClr val="2A2B2E"/>
+                </a:solidFill>
+                <a:effectLst/>
+                <a:latin typeface="Times New Roman" panose="02020603050405020304" pitchFamily="18" charset="0"/>
+                <a:cs typeface="Times New Roman" panose="02020603050405020304" pitchFamily="18" charset="0"/>
               </a:rPr>
-              <a:t>互联网隐式情感周报</a:t>
+              <a:t>Internet Implicit Emotion Week Report</a:t>
             </a:r>
             <a:endParaRPr lang="en-US" altLang="zh-CN" sz="4300" dirty="0">
-              <a:latin typeface="楷体" panose="02010609060101010101" pitchFamily="49" charset="-122"/>
+              <a:latin typeface="Times New Roman" panose="02020603050405020304" pitchFamily="18" charset="0"/>
               <a:ea typeface="楷体" panose="02010609060101010101" pitchFamily="49" charset="-122"/>
+              <a:cs typeface="Times New Roman" panose="02020603050405020304" pitchFamily="18" charset="0"/>
             </a:endParaRPr>
           </a:p>
         </p:txBody>
@@ -3698,8 +3704,8 @@
         </p:nvSpPr>
         <p:spPr>
           <a:xfrm>
-            <a:off x="3952356" y="3006663"/>
-            <a:ext cx="3633848" cy="523220"/>
+            <a:off x="4379869" y="3039405"/>
+            <a:ext cx="2950115" cy="523220"/>
           </a:xfrm>
           <a:prstGeom prst="rect">
             <a:avLst/>
@@ -3714,33 +3720,16 @@
           <a:p>
             <a:r>
               <a:rPr lang="en-US" altLang="zh-CN" sz="2800" dirty="0">
-                <a:latin typeface="楷体" panose="02010609060101010101" pitchFamily="49" charset="-122"/>
+                <a:latin typeface="Times New Roman" panose="02020603050405020304" pitchFamily="18" charset="0"/>
                 <a:ea typeface="楷体" panose="02010609060101010101" pitchFamily="49" charset="-122"/>
+                <a:cs typeface="Times New Roman" panose="02020603050405020304" pitchFamily="18" charset="0"/>
               </a:rPr>
-              <a:t>-2023</a:t>
-            </a:r>
-            <a:r>
-              <a:rPr lang="zh-CN" altLang="en-US" sz="2800" dirty="0">
-                <a:latin typeface="楷体" panose="02010609060101010101" pitchFamily="49" charset="-122"/>
-                <a:ea typeface="楷体" panose="02010609060101010101" pitchFamily="49" charset="-122"/>
-              </a:rPr>
-              <a:t>年</a:t>
-            </a:r>
-            <a:r>
-              <a:rPr lang="en-US" altLang="zh-CN" sz="2800" dirty="0">
-                <a:latin typeface="楷体" panose="02010609060101010101" pitchFamily="49" charset="-122"/>
-                <a:ea typeface="楷体" panose="02010609060101010101" pitchFamily="49" charset="-122"/>
-              </a:rPr>
-              <a:t>6</a:t>
-            </a:r>
-            <a:r>
-              <a:rPr lang="zh-CN" altLang="en-US" sz="2800" dirty="0">
-                <a:latin typeface="楷体" panose="02010609060101010101" pitchFamily="49" charset="-122"/>
-                <a:ea typeface="楷体" panose="02010609060101010101" pitchFamily="49" charset="-122"/>
-              </a:rPr>
-              <a:t>月第一期</a:t>
-            </a:r>
-            <a:endParaRPr lang="zh-CN" altLang="en-US" sz="2800" dirty="0"/>
+              <a:t>2022 September 1</a:t>
+            </a:r>
+            <a:endParaRPr lang="zh-CN" altLang="en-US" sz="2800" dirty="0">
+              <a:latin typeface="Times New Roman" panose="02020603050405020304" pitchFamily="18" charset="0"/>
+              <a:cs typeface="Times New Roman" panose="02020603050405020304" pitchFamily="18" charset="0"/>
+            </a:endParaRPr>
           </a:p>
         </p:txBody>
       </p:sp>
@@ -3758,8 +3747,8 @@
         </p:nvSpPr>
         <p:spPr>
           <a:xfrm>
-            <a:off x="5676901" y="8906368"/>
-            <a:ext cx="1225570" cy="369332"/>
+            <a:off x="4785755" y="8882618"/>
+            <a:ext cx="2318596" cy="369332"/>
           </a:xfrm>
           <a:prstGeom prst="rect">
             <a:avLst/>
@@ -3773,13 +3762,17 @@
           <a:lstStyle/>
           <a:p>
             <a:r>
-              <a:rPr lang="zh-CN" altLang="en-US" dirty="0">
-                <a:latin typeface="楷体" panose="02010609060101010101" pitchFamily="49" charset="-122"/>
+              <a:rPr lang="en-US" altLang="zh-CN" dirty="0">
+                <a:latin typeface="Times New Roman" panose="02020603050405020304" pitchFamily="18" charset="0"/>
                 <a:ea typeface="楷体" panose="02010609060101010101" pitchFamily="49" charset="-122"/>
+                <a:cs typeface="Times New Roman" panose="02020603050405020304" pitchFamily="18" charset="0"/>
               </a:rPr>
-              <a:t>此处翻页</a:t>
-            </a:r>
-            <a:endParaRPr lang="zh-CN" altLang="en-US" dirty="0"/>
+              <a:t>Turn the page here</a:t>
+            </a:r>
+            <a:endParaRPr lang="zh-CN" altLang="en-US" dirty="0">
+              <a:latin typeface="Times New Roman" panose="02020603050405020304" pitchFamily="18" charset="0"/>
+              <a:cs typeface="Times New Roman" panose="02020603050405020304" pitchFamily="18" charset="0"/>
+            </a:endParaRPr>
           </a:p>
         </p:txBody>
       </p:sp>

</xml_diff>

<commit_message>
Site updated: 2023-06-26 00:35:38
</commit_message>
<xml_diff>
--- a/demo/sarcasm/jiaoben2304/first_page.pptx
+++ b/demo/sarcasm/jiaoben2304/first_page.pptx
@@ -5,12 +5,13 @@
     <p:sldMasterId id="2147483696" r:id="rId1"/>
   </p:sldMasterIdLst>
   <p:notesMasterIdLst>
-    <p:notesMasterId r:id="rId5"/>
+    <p:notesMasterId r:id="rId6"/>
   </p:notesMasterIdLst>
   <p:sldIdLst>
     <p:sldId id="256" r:id="rId2"/>
-    <p:sldId id="257" r:id="rId3"/>
-    <p:sldId id="258" r:id="rId4"/>
+    <p:sldId id="259" r:id="rId3"/>
+    <p:sldId id="257" r:id="rId4"/>
+    <p:sldId id="258" r:id="rId5"/>
   </p:sldIdLst>
   <p:sldSz cx="7199313" cy="9361488"/>
   <p:notesSz cx="6858000" cy="9144000"/>
@@ -199,7 +200,7 @@
           <a:p>
             <a:fld id="{9F2C887D-13CF-45CF-8BA1-CEA69189E219}" type="datetimeFigureOut">
               <a:rPr lang="zh-CN" altLang="en-US" smtClean="0"/>
-              <a:t>2023/6/23</a:t>
+              <a:t>2023/6/25</a:t>
             </a:fld>
             <a:endParaRPr lang="zh-CN" altLang="en-US"/>
           </a:p>
@@ -624,7 +625,7 @@
     </p:spTree>
     <p:extLst>
       <p:ext uri="{BB962C8B-B14F-4D97-AF65-F5344CB8AC3E}">
-        <p14:creationId xmlns:p14="http://schemas.microsoft.com/office/powerpoint/2010/main" val="2788211362"/>
+        <p14:creationId xmlns:p14="http://schemas.microsoft.com/office/powerpoint/2010/main" val="885031543"/>
       </p:ext>
     </p:extLst>
   </p:cSld>
@@ -700,6 +701,90 @@
             <a:fld id="{E51998DA-4F9D-40AD-B946-223C6F8A8A4E}" type="slidenum">
               <a:rPr lang="zh-CN" altLang="en-US" smtClean="0"/>
               <a:t>3</a:t>
+            </a:fld>
+            <a:endParaRPr lang="zh-CN" altLang="en-US"/>
+          </a:p>
+        </p:txBody>
+      </p:sp>
+    </p:spTree>
+    <p:extLst>
+      <p:ext uri="{BB962C8B-B14F-4D97-AF65-F5344CB8AC3E}">
+        <p14:creationId xmlns:p14="http://schemas.microsoft.com/office/powerpoint/2010/main" val="2788211362"/>
+      </p:ext>
+    </p:extLst>
+  </p:cSld>
+  <p:clrMapOvr>
+    <a:masterClrMapping/>
+  </p:clrMapOvr>
+</p:notes>
+</file>
+
+<file path=ppt/notesSlides/notesSlide4.xml><?xml version="1.0" encoding="utf-8"?>
+<p:notes xmlns:a="http://schemas.openxmlformats.org/drawingml/2006/main" xmlns:r="http://schemas.openxmlformats.org/officeDocument/2006/relationships" xmlns:p="http://schemas.openxmlformats.org/presentationml/2006/main">
+  <p:cSld>
+    <p:spTree>
+      <p:nvGrpSpPr>
+        <p:cNvPr id="1" name=""/>
+        <p:cNvGrpSpPr/>
+        <p:nvPr/>
+      </p:nvGrpSpPr>
+      <p:grpSpPr>
+        <a:xfrm>
+          <a:off x="0" y="0"/>
+          <a:ext cx="0" cy="0"/>
+          <a:chOff x="0" y="0"/>
+          <a:chExt cx="0" cy="0"/>
+        </a:xfrm>
+      </p:grpSpPr>
+      <p:sp>
+        <p:nvSpPr>
+          <p:cNvPr id="2" name="幻灯片图像占位符 1"/>
+          <p:cNvSpPr>
+            <a:spLocks noGrp="1" noRot="1" noChangeAspect="1"/>
+          </p:cNvSpPr>
+          <p:nvPr>
+            <p:ph type="sldImg"/>
+          </p:nvPr>
+        </p:nvSpPr>
+        <p:spPr/>
+      </p:sp>
+      <p:sp>
+        <p:nvSpPr>
+          <p:cNvPr id="3" name="备注占位符 2"/>
+          <p:cNvSpPr>
+            <a:spLocks noGrp="1"/>
+          </p:cNvSpPr>
+          <p:nvPr>
+            <p:ph type="body" idx="1"/>
+          </p:nvPr>
+        </p:nvSpPr>
+        <p:spPr/>
+        <p:txBody>
+          <a:bodyPr/>
+          <a:lstStyle/>
+          <a:p>
+            <a:endParaRPr lang="zh-CN" altLang="en-US" dirty="0"/>
+          </a:p>
+        </p:txBody>
+      </p:sp>
+      <p:sp>
+        <p:nvSpPr>
+          <p:cNvPr id="4" name="灯片编号占位符 3"/>
+          <p:cNvSpPr>
+            <a:spLocks noGrp="1"/>
+          </p:cNvSpPr>
+          <p:nvPr>
+            <p:ph type="sldNum" sz="quarter" idx="5"/>
+          </p:nvPr>
+        </p:nvSpPr>
+        <p:spPr/>
+        <p:txBody>
+          <a:bodyPr/>
+          <a:lstStyle/>
+          <a:p>
+            <a:fld id="{E51998DA-4F9D-40AD-B946-223C6F8A8A4E}" type="slidenum">
+              <a:rPr lang="zh-CN" altLang="en-US" smtClean="0"/>
+              <a:t>4</a:t>
             </a:fld>
             <a:endParaRPr lang="zh-CN" altLang="en-US"/>
           </a:p>
@@ -849,7 +934,7 @@
           <a:p>
             <a:fld id="{7F066AC1-9EBE-4FAC-AB84-7C4667A0BEE3}" type="datetimeFigureOut">
               <a:rPr lang="zh-CN" altLang="en-US" smtClean="0"/>
-              <a:t>2023/6/23</a:t>
+              <a:t>2023/6/25</a:t>
             </a:fld>
             <a:endParaRPr lang="zh-CN" altLang="en-US"/>
           </a:p>
@@ -1019,7 +1104,7 @@
           <a:p>
             <a:fld id="{7F066AC1-9EBE-4FAC-AB84-7C4667A0BEE3}" type="datetimeFigureOut">
               <a:rPr lang="zh-CN" altLang="en-US" smtClean="0"/>
-              <a:t>2023/6/23</a:t>
+              <a:t>2023/6/25</a:t>
             </a:fld>
             <a:endParaRPr lang="zh-CN" altLang="en-US"/>
           </a:p>
@@ -1199,7 +1284,7 @@
           <a:p>
             <a:fld id="{7F066AC1-9EBE-4FAC-AB84-7C4667A0BEE3}" type="datetimeFigureOut">
               <a:rPr lang="zh-CN" altLang="en-US" smtClean="0"/>
-              <a:t>2023/6/23</a:t>
+              <a:t>2023/6/25</a:t>
             </a:fld>
             <a:endParaRPr lang="zh-CN" altLang="en-US"/>
           </a:p>
@@ -1369,7 +1454,7 @@
           <a:p>
             <a:fld id="{7F066AC1-9EBE-4FAC-AB84-7C4667A0BEE3}" type="datetimeFigureOut">
               <a:rPr lang="zh-CN" altLang="en-US" smtClean="0"/>
-              <a:t>2023/6/23</a:t>
+              <a:t>2023/6/25</a:t>
             </a:fld>
             <a:endParaRPr lang="zh-CN" altLang="en-US"/>
           </a:p>
@@ -1613,7 +1698,7 @@
           <a:p>
             <a:fld id="{7F066AC1-9EBE-4FAC-AB84-7C4667A0BEE3}" type="datetimeFigureOut">
               <a:rPr lang="zh-CN" altLang="en-US" smtClean="0"/>
-              <a:t>2023/6/23</a:t>
+              <a:t>2023/6/25</a:t>
             </a:fld>
             <a:endParaRPr lang="zh-CN" altLang="en-US"/>
           </a:p>
@@ -1845,7 +1930,7 @@
           <a:p>
             <a:fld id="{7F066AC1-9EBE-4FAC-AB84-7C4667A0BEE3}" type="datetimeFigureOut">
               <a:rPr lang="zh-CN" altLang="en-US" smtClean="0"/>
-              <a:t>2023/6/23</a:t>
+              <a:t>2023/6/25</a:t>
             </a:fld>
             <a:endParaRPr lang="zh-CN" altLang="en-US"/>
           </a:p>
@@ -2212,7 +2297,7 @@
           <a:p>
             <a:fld id="{7F066AC1-9EBE-4FAC-AB84-7C4667A0BEE3}" type="datetimeFigureOut">
               <a:rPr lang="zh-CN" altLang="en-US" smtClean="0"/>
-              <a:t>2023/6/23</a:t>
+              <a:t>2023/6/25</a:t>
             </a:fld>
             <a:endParaRPr lang="zh-CN" altLang="en-US"/>
           </a:p>
@@ -2330,7 +2415,7 @@
           <a:p>
             <a:fld id="{7F066AC1-9EBE-4FAC-AB84-7C4667A0BEE3}" type="datetimeFigureOut">
               <a:rPr lang="zh-CN" altLang="en-US" smtClean="0"/>
-              <a:t>2023/6/23</a:t>
+              <a:t>2023/6/25</a:t>
             </a:fld>
             <a:endParaRPr lang="zh-CN" altLang="en-US"/>
           </a:p>
@@ -2425,7 +2510,7 @@
           <a:p>
             <a:fld id="{7F066AC1-9EBE-4FAC-AB84-7C4667A0BEE3}" type="datetimeFigureOut">
               <a:rPr lang="zh-CN" altLang="en-US" smtClean="0"/>
-              <a:t>2023/6/23</a:t>
+              <a:t>2023/6/25</a:t>
             </a:fld>
             <a:endParaRPr lang="zh-CN" altLang="en-US"/>
           </a:p>
@@ -2702,7 +2787,7 @@
           <a:p>
             <a:fld id="{7F066AC1-9EBE-4FAC-AB84-7C4667A0BEE3}" type="datetimeFigureOut">
               <a:rPr lang="zh-CN" altLang="en-US" smtClean="0"/>
-              <a:t>2023/6/23</a:t>
+              <a:t>2023/6/25</a:t>
             </a:fld>
             <a:endParaRPr lang="zh-CN" altLang="en-US"/>
           </a:p>
@@ -2959,7 +3044,7 @@
           <a:p>
             <a:fld id="{7F066AC1-9EBE-4FAC-AB84-7C4667A0BEE3}" type="datetimeFigureOut">
               <a:rPr lang="zh-CN" altLang="en-US" smtClean="0"/>
-              <a:t>2023/6/23</a:t>
+              <a:t>2023/6/25</a:t>
             </a:fld>
             <a:endParaRPr lang="zh-CN" altLang="en-US"/>
           </a:p>
@@ -3172,7 +3257,7 @@
           <a:p>
             <a:fld id="{7F066AC1-9EBE-4FAC-AB84-7C4667A0BEE3}" type="datetimeFigureOut">
               <a:rPr lang="zh-CN" altLang="en-US" smtClean="0"/>
-              <a:t>2023/6/23</a:t>
+              <a:t>2023/6/25</a:t>
             </a:fld>
             <a:endParaRPr lang="zh-CN" altLang="en-US"/>
           </a:p>
@@ -3894,6 +3979,297 @@
           </a:prstGeom>
         </p:spPr>
       </p:pic>
+      <p:sp>
+        <p:nvSpPr>
+          <p:cNvPr id="5" name="文本框 4">
+            <a:extLst>
+              <a:ext uri="{FF2B5EF4-FFF2-40B4-BE49-F238E27FC236}">
+                <a16:creationId xmlns:a16="http://schemas.microsoft.com/office/drawing/2014/main" id="{9E1D2235-05F0-E3F4-ACD4-2B4429ED1069}"/>
+              </a:ext>
+            </a:extLst>
+          </p:cNvPr>
+          <p:cNvSpPr txBox="1"/>
+          <p:nvPr/>
+        </p:nvSpPr>
+        <p:spPr>
+          <a:xfrm>
+            <a:off x="42756" y="1047514"/>
+            <a:ext cx="5296394" cy="769441"/>
+          </a:xfrm>
+          <a:prstGeom prst="rect">
+            <a:avLst/>
+          </a:prstGeom>
+          <a:noFill/>
+        </p:spPr>
+        <p:txBody>
+          <a:bodyPr wrap="square">
+            <a:spAutoFit/>
+          </a:bodyPr>
+          <a:lstStyle/>
+          <a:p>
+            <a:pPr algn="ctr"/>
+            <a:r>
+              <a:rPr lang="zh-CN" altLang="en-US" sz="4400" b="0" i="0" dirty="0">
+                <a:solidFill>
+                  <a:srgbClr val="2A2B2E"/>
+                </a:solidFill>
+                <a:effectLst/>
+                <a:latin typeface="楷体" panose="02010609060101010101" pitchFamily="49" charset="-122"/>
+                <a:ea typeface="楷体" panose="02010609060101010101" pitchFamily="49" charset="-122"/>
+                <a:cs typeface="Times New Roman" panose="02020603050405020304" pitchFamily="18" charset="0"/>
+              </a:rPr>
+              <a:t>互联网隐式情感周报</a:t>
+            </a:r>
+            <a:endParaRPr lang="en-US" altLang="zh-CN" sz="4300" dirty="0">
+              <a:latin typeface="楷体" panose="02010609060101010101" pitchFamily="49" charset="-122"/>
+              <a:ea typeface="楷体" panose="02010609060101010101" pitchFamily="49" charset="-122"/>
+              <a:cs typeface="Times New Roman" panose="02020603050405020304" pitchFamily="18" charset="0"/>
+            </a:endParaRPr>
+          </a:p>
+        </p:txBody>
+      </p:sp>
+      <p:pic>
+        <p:nvPicPr>
+          <p:cNvPr id="7" name="图片 6">
+            <a:extLst>
+              <a:ext uri="{FF2B5EF4-FFF2-40B4-BE49-F238E27FC236}">
+                <a16:creationId xmlns:a16="http://schemas.microsoft.com/office/drawing/2014/main" id="{EA8DB766-A755-BD81-B1C1-94AC56F776EB}"/>
+              </a:ext>
+            </a:extLst>
+          </p:cNvPr>
+          <p:cNvPicPr>
+            <a:picLocks noChangeAspect="1"/>
+          </p:cNvPicPr>
+          <p:nvPr/>
+        </p:nvPicPr>
+        <p:blipFill rotWithShape="1">
+          <a:blip r:embed="rId4"/>
+          <a:srcRect l="21229" t="10485" r="28140" b="8540"/>
+          <a:stretch/>
+        </p:blipFill>
+        <p:spPr>
+          <a:xfrm>
+            <a:off x="5266457" y="179388"/>
+            <a:ext cx="1743545" cy="2505694"/>
+          </a:xfrm>
+          <a:prstGeom prst="rect">
+            <a:avLst/>
+          </a:prstGeom>
+        </p:spPr>
+      </p:pic>
+      <p:sp>
+        <p:nvSpPr>
+          <p:cNvPr id="11" name="文本框 10">
+            <a:extLst>
+              <a:ext uri="{FF2B5EF4-FFF2-40B4-BE49-F238E27FC236}">
+                <a16:creationId xmlns:a16="http://schemas.microsoft.com/office/drawing/2014/main" id="{20105A35-3606-2950-3B9C-09BD5D35358C}"/>
+              </a:ext>
+            </a:extLst>
+          </p:cNvPr>
+          <p:cNvSpPr txBox="1"/>
+          <p:nvPr/>
+        </p:nvSpPr>
+        <p:spPr>
+          <a:xfrm>
+            <a:off x="4385530" y="3091543"/>
+            <a:ext cx="2813783" cy="461665"/>
+          </a:xfrm>
+          <a:prstGeom prst="rect">
+            <a:avLst/>
+          </a:prstGeom>
+          <a:noFill/>
+        </p:spPr>
+        <p:txBody>
+          <a:bodyPr wrap="square">
+            <a:spAutoFit/>
+          </a:bodyPr>
+          <a:lstStyle/>
+          <a:p>
+            <a:r>
+              <a:rPr lang="en-US" altLang="zh-CN" sz="2400" dirty="0">
+                <a:latin typeface="楷体" panose="02010609060101010101" pitchFamily="49" charset="-122"/>
+                <a:ea typeface="楷体" panose="02010609060101010101" pitchFamily="49" charset="-122"/>
+                <a:cs typeface="Times New Roman" panose="02020603050405020304" pitchFamily="18" charset="0"/>
+              </a:rPr>
+              <a:t>2022</a:t>
+            </a:r>
+            <a:r>
+              <a:rPr lang="zh-CN" altLang="en-US" sz="2400">
+                <a:latin typeface="楷体" panose="02010609060101010101" pitchFamily="49" charset="-122"/>
+                <a:ea typeface="楷体" panose="02010609060101010101" pitchFamily="49" charset="-122"/>
+                <a:cs typeface="Times New Roman" panose="02020603050405020304" pitchFamily="18" charset="0"/>
+              </a:rPr>
+              <a:t>年九月第二期</a:t>
+            </a:r>
+            <a:endParaRPr lang="zh-CN" altLang="en-US" sz="2400" dirty="0">
+              <a:latin typeface="楷体" panose="02010609060101010101" pitchFamily="49" charset="-122"/>
+              <a:ea typeface="楷体" panose="02010609060101010101" pitchFamily="49" charset="-122"/>
+              <a:cs typeface="Times New Roman" panose="02020603050405020304" pitchFamily="18" charset="0"/>
+            </a:endParaRPr>
+          </a:p>
+        </p:txBody>
+      </p:sp>
+      <p:sp>
+        <p:nvSpPr>
+          <p:cNvPr id="2" name="文本框 1">
+            <a:extLst>
+              <a:ext uri="{FF2B5EF4-FFF2-40B4-BE49-F238E27FC236}">
+                <a16:creationId xmlns:a16="http://schemas.microsoft.com/office/drawing/2014/main" id="{AB21E411-B6DF-AF73-F1C5-2D0702B9BBB3}"/>
+              </a:ext>
+            </a:extLst>
+          </p:cNvPr>
+          <p:cNvSpPr txBox="1"/>
+          <p:nvPr/>
+        </p:nvSpPr>
+        <p:spPr>
+          <a:xfrm>
+            <a:off x="5675101" y="8882618"/>
+            <a:ext cx="1151582" cy="369332"/>
+          </a:xfrm>
+          <a:prstGeom prst="rect">
+            <a:avLst/>
+          </a:prstGeom>
+          <a:noFill/>
+        </p:spPr>
+        <p:txBody>
+          <a:bodyPr wrap="square">
+            <a:spAutoFit/>
+          </a:bodyPr>
+          <a:lstStyle/>
+          <a:p>
+            <a:r>
+              <a:rPr lang="zh-CN" altLang="en-US" dirty="0">
+                <a:latin typeface="Times New Roman" panose="02020603050405020304" pitchFamily="18" charset="0"/>
+                <a:ea typeface="楷体" panose="02010609060101010101" pitchFamily="49" charset="-122"/>
+                <a:cs typeface="Times New Roman" panose="02020603050405020304" pitchFamily="18" charset="0"/>
+              </a:rPr>
+              <a:t>此处翻页</a:t>
+            </a:r>
+            <a:endParaRPr lang="zh-CN" altLang="en-US" dirty="0">
+              <a:latin typeface="Times New Roman" panose="02020603050405020304" pitchFamily="18" charset="0"/>
+              <a:cs typeface="Times New Roman" panose="02020603050405020304" pitchFamily="18" charset="0"/>
+            </a:endParaRPr>
+          </a:p>
+        </p:txBody>
+      </p:sp>
+      <p:sp>
+        <p:nvSpPr>
+          <p:cNvPr id="6" name="箭头: 右 5">
+            <a:extLst>
+              <a:ext uri="{FF2B5EF4-FFF2-40B4-BE49-F238E27FC236}">
+                <a16:creationId xmlns:a16="http://schemas.microsoft.com/office/drawing/2014/main" id="{F164D18F-7E80-5FDF-3832-0414D5624C9E}"/>
+              </a:ext>
+            </a:extLst>
+          </p:cNvPr>
+          <p:cNvSpPr/>
+          <p:nvPr/>
+        </p:nvSpPr>
+        <p:spPr>
+          <a:xfrm>
+            <a:off x="6727397" y="9053002"/>
+            <a:ext cx="297656" cy="76064"/>
+          </a:xfrm>
+          <a:prstGeom prst="rightArrow">
+            <a:avLst>
+              <a:gd name="adj1" fmla="val 30534"/>
+              <a:gd name="adj2" fmla="val 144348"/>
+            </a:avLst>
+          </a:prstGeom>
+          <a:solidFill>
+            <a:schemeClr val="tx1"/>
+          </a:solidFill>
+        </p:spPr>
+        <p:style>
+          <a:lnRef idx="2">
+            <a:schemeClr val="accent1">
+              <a:shade val="15000"/>
+            </a:schemeClr>
+          </a:lnRef>
+          <a:fillRef idx="1">
+            <a:schemeClr val="accent1"/>
+          </a:fillRef>
+          <a:effectRef idx="0">
+            <a:schemeClr val="accent1"/>
+          </a:effectRef>
+          <a:fontRef idx="minor">
+            <a:schemeClr val="lt1"/>
+          </a:fontRef>
+        </p:style>
+        <p:txBody>
+          <a:bodyPr rtlCol="0" anchor="ctr"/>
+          <a:lstStyle/>
+          <a:p>
+            <a:pPr algn="ctr"/>
+            <a:endParaRPr lang="zh-CN" altLang="en-US"/>
+          </a:p>
+        </p:txBody>
+      </p:sp>
+    </p:spTree>
+    <p:extLst>
+      <p:ext uri="{BB962C8B-B14F-4D97-AF65-F5344CB8AC3E}">
+        <p14:creationId xmlns:p14="http://schemas.microsoft.com/office/powerpoint/2010/main" val="1822966338"/>
+      </p:ext>
+    </p:extLst>
+  </p:cSld>
+  <p:clrMapOvr>
+    <a:masterClrMapping/>
+  </p:clrMapOvr>
+</p:sld>
+</file>
+
+<file path=ppt/slides/slide3.xml><?xml version="1.0" encoding="utf-8"?>
+<p:sld xmlns:a="http://schemas.openxmlformats.org/drawingml/2006/main" xmlns:r="http://schemas.openxmlformats.org/officeDocument/2006/relationships" xmlns:p="http://schemas.openxmlformats.org/presentationml/2006/main">
+  <p:cSld>
+    <p:spTree>
+      <p:nvGrpSpPr>
+        <p:cNvPr id="1" name=""/>
+        <p:cNvGrpSpPr/>
+        <p:nvPr/>
+      </p:nvGrpSpPr>
+      <p:grpSpPr>
+        <a:xfrm>
+          <a:off x="0" y="0"/>
+          <a:ext cx="0" cy="0"/>
+          <a:chOff x="0" y="0"/>
+          <a:chExt cx="0" cy="0"/>
+        </a:xfrm>
+      </p:grpSpPr>
+      <p:pic>
+        <p:nvPicPr>
+          <p:cNvPr id="9" name="图片 8">
+            <a:extLst>
+              <a:ext uri="{FF2B5EF4-FFF2-40B4-BE49-F238E27FC236}">
+                <a16:creationId xmlns:a16="http://schemas.microsoft.com/office/drawing/2014/main" id="{87A7E7A4-38BB-5890-055A-928A030CFFE5}"/>
+              </a:ext>
+            </a:extLst>
+          </p:cNvPr>
+          <p:cNvPicPr>
+            <a:picLocks noChangeAspect="1"/>
+          </p:cNvPicPr>
+          <p:nvPr/>
+        </p:nvPicPr>
+        <p:blipFill>
+          <a:blip r:embed="rId3">
+            <a:extLst>
+              <a:ext uri="{28A0092B-C50C-407E-A947-70E740481C1C}">
+                <a14:useLocalDpi xmlns:a14="http://schemas.microsoft.com/office/drawing/2010/main" val="0"/>
+              </a:ext>
+            </a:extLst>
+          </a:blip>
+          <a:stretch>
+            <a:fillRect/>
+          </a:stretch>
+        </p:blipFill>
+        <p:spPr>
+          <a:xfrm>
+            <a:off x="115449" y="101600"/>
+            <a:ext cx="6968415" cy="9131300"/>
+          </a:xfrm>
+          <a:prstGeom prst="rect">
+            <a:avLst/>
+          </a:prstGeom>
+        </p:spPr>
+      </p:pic>
       <p:pic>
         <p:nvPicPr>
           <p:cNvPr id="7" name="图片 6">
@@ -3936,7 +4312,7 @@
 </p:sld>
 </file>
 
-<file path=ppt/slides/slide3.xml><?xml version="1.0" encoding="utf-8"?>
+<file path=ppt/slides/slide4.xml><?xml version="1.0" encoding="utf-8"?>
 <p:sld xmlns:a="http://schemas.openxmlformats.org/drawingml/2006/main" xmlns:r="http://schemas.openxmlformats.org/officeDocument/2006/relationships" xmlns:p="http://schemas.openxmlformats.org/presentationml/2006/main">
   <p:cSld>
     <p:spTree>

</xml_diff>

<commit_message>
Site updated: 2023-06-29 01:34:47
</commit_message>
<xml_diff>
--- a/demo/sarcasm/jiaoben2304/first_page.pptx
+++ b/demo/sarcasm/jiaoben2304/first_page.pptx
@@ -200,7 +200,7 @@
           <a:p>
             <a:fld id="{9F2C887D-13CF-45CF-8BA1-CEA69189E219}" type="datetimeFigureOut">
               <a:rPr lang="zh-CN" altLang="en-US" smtClean="0"/>
-              <a:t>2023/6/25</a:t>
+              <a:t>2023/6/28</a:t>
             </a:fld>
             <a:endParaRPr lang="zh-CN" altLang="en-US"/>
           </a:p>
@@ -934,7 +934,7 @@
           <a:p>
             <a:fld id="{7F066AC1-9EBE-4FAC-AB84-7C4667A0BEE3}" type="datetimeFigureOut">
               <a:rPr lang="zh-CN" altLang="en-US" smtClean="0"/>
-              <a:t>2023/6/25</a:t>
+              <a:t>2023/6/28</a:t>
             </a:fld>
             <a:endParaRPr lang="zh-CN" altLang="en-US"/>
           </a:p>
@@ -1104,7 +1104,7 @@
           <a:p>
             <a:fld id="{7F066AC1-9EBE-4FAC-AB84-7C4667A0BEE3}" type="datetimeFigureOut">
               <a:rPr lang="zh-CN" altLang="en-US" smtClean="0"/>
-              <a:t>2023/6/25</a:t>
+              <a:t>2023/6/28</a:t>
             </a:fld>
             <a:endParaRPr lang="zh-CN" altLang="en-US"/>
           </a:p>
@@ -1284,7 +1284,7 @@
           <a:p>
             <a:fld id="{7F066AC1-9EBE-4FAC-AB84-7C4667A0BEE3}" type="datetimeFigureOut">
               <a:rPr lang="zh-CN" altLang="en-US" smtClean="0"/>
-              <a:t>2023/6/25</a:t>
+              <a:t>2023/6/28</a:t>
             </a:fld>
             <a:endParaRPr lang="zh-CN" altLang="en-US"/>
           </a:p>
@@ -1454,7 +1454,7 @@
           <a:p>
             <a:fld id="{7F066AC1-9EBE-4FAC-AB84-7C4667A0BEE3}" type="datetimeFigureOut">
               <a:rPr lang="zh-CN" altLang="en-US" smtClean="0"/>
-              <a:t>2023/6/25</a:t>
+              <a:t>2023/6/28</a:t>
             </a:fld>
             <a:endParaRPr lang="zh-CN" altLang="en-US"/>
           </a:p>
@@ -1698,7 +1698,7 @@
           <a:p>
             <a:fld id="{7F066AC1-9EBE-4FAC-AB84-7C4667A0BEE3}" type="datetimeFigureOut">
               <a:rPr lang="zh-CN" altLang="en-US" smtClean="0"/>
-              <a:t>2023/6/25</a:t>
+              <a:t>2023/6/28</a:t>
             </a:fld>
             <a:endParaRPr lang="zh-CN" altLang="en-US"/>
           </a:p>
@@ -1930,7 +1930,7 @@
           <a:p>
             <a:fld id="{7F066AC1-9EBE-4FAC-AB84-7C4667A0BEE3}" type="datetimeFigureOut">
               <a:rPr lang="zh-CN" altLang="en-US" smtClean="0"/>
-              <a:t>2023/6/25</a:t>
+              <a:t>2023/6/28</a:t>
             </a:fld>
             <a:endParaRPr lang="zh-CN" altLang="en-US"/>
           </a:p>
@@ -2297,7 +2297,7 @@
           <a:p>
             <a:fld id="{7F066AC1-9EBE-4FAC-AB84-7C4667A0BEE3}" type="datetimeFigureOut">
               <a:rPr lang="zh-CN" altLang="en-US" smtClean="0"/>
-              <a:t>2023/6/25</a:t>
+              <a:t>2023/6/28</a:t>
             </a:fld>
             <a:endParaRPr lang="zh-CN" altLang="en-US"/>
           </a:p>
@@ -2415,7 +2415,7 @@
           <a:p>
             <a:fld id="{7F066AC1-9EBE-4FAC-AB84-7C4667A0BEE3}" type="datetimeFigureOut">
               <a:rPr lang="zh-CN" altLang="en-US" smtClean="0"/>
-              <a:t>2023/6/25</a:t>
+              <a:t>2023/6/28</a:t>
             </a:fld>
             <a:endParaRPr lang="zh-CN" altLang="en-US"/>
           </a:p>
@@ -2510,7 +2510,7 @@
           <a:p>
             <a:fld id="{7F066AC1-9EBE-4FAC-AB84-7C4667A0BEE3}" type="datetimeFigureOut">
               <a:rPr lang="zh-CN" altLang="en-US" smtClean="0"/>
-              <a:t>2023/6/25</a:t>
+              <a:t>2023/6/28</a:t>
             </a:fld>
             <a:endParaRPr lang="zh-CN" altLang="en-US"/>
           </a:p>
@@ -2787,7 +2787,7 @@
           <a:p>
             <a:fld id="{7F066AC1-9EBE-4FAC-AB84-7C4667A0BEE3}" type="datetimeFigureOut">
               <a:rPr lang="zh-CN" altLang="en-US" smtClean="0"/>
-              <a:t>2023/6/25</a:t>
+              <a:t>2023/6/28</a:t>
             </a:fld>
             <a:endParaRPr lang="zh-CN" altLang="en-US"/>
           </a:p>
@@ -3044,7 +3044,7 @@
           <a:p>
             <a:fld id="{7F066AC1-9EBE-4FAC-AB84-7C4667A0BEE3}" type="datetimeFigureOut">
               <a:rPr lang="zh-CN" altLang="en-US" smtClean="0"/>
-              <a:t>2023/6/25</a:t>
+              <a:t>2023/6/28</a:t>
             </a:fld>
             <a:endParaRPr lang="zh-CN" altLang="en-US"/>
           </a:p>
@@ -3257,7 +3257,7 @@
           <a:p>
             <a:fld id="{7F066AC1-9EBE-4FAC-AB84-7C4667A0BEE3}" type="datetimeFigureOut">
               <a:rPr lang="zh-CN" altLang="en-US" smtClean="0"/>
-              <a:t>2023/6/25</a:t>
+              <a:t>2023/6/28</a:t>
             </a:fld>
             <a:endParaRPr lang="zh-CN" altLang="en-US"/>
           </a:p>
@@ -4099,7 +4099,7 @@
                 <a:ea typeface="楷体" panose="02010609060101010101" pitchFamily="49" charset="-122"/>
                 <a:cs typeface="Times New Roman" panose="02020603050405020304" pitchFamily="18" charset="0"/>
               </a:rPr>
-              <a:t>年九月第二期</a:t>
+              <a:t>年九月第一期</a:t>
             </a:r>
             <a:endParaRPr lang="zh-CN" altLang="en-US" sz="2400" dirty="0">
               <a:latin typeface="楷体" panose="02010609060101010101" pitchFamily="49" charset="-122"/>

</xml_diff>

<commit_message>
Site updated: 2023-07-01 01:51:16
</commit_message>
<xml_diff>
--- a/demo/sarcasm/jiaoben2304/first_page.pptx
+++ b/demo/sarcasm/jiaoben2304/first_page.pptx
@@ -200,7 +200,7 @@
           <a:p>
             <a:fld id="{9F2C887D-13CF-45CF-8BA1-CEA69189E219}" type="datetimeFigureOut">
               <a:rPr lang="zh-CN" altLang="en-US" smtClean="0"/>
-              <a:t>2023/6/28</a:t>
+              <a:t>2023/7/1</a:t>
             </a:fld>
             <a:endParaRPr lang="zh-CN" altLang="en-US"/>
           </a:p>
@@ -934,7 +934,7 @@
           <a:p>
             <a:fld id="{7F066AC1-9EBE-4FAC-AB84-7C4667A0BEE3}" type="datetimeFigureOut">
               <a:rPr lang="zh-CN" altLang="en-US" smtClean="0"/>
-              <a:t>2023/6/28</a:t>
+              <a:t>2023/7/1</a:t>
             </a:fld>
             <a:endParaRPr lang="zh-CN" altLang="en-US"/>
           </a:p>
@@ -1104,7 +1104,7 @@
           <a:p>
             <a:fld id="{7F066AC1-9EBE-4FAC-AB84-7C4667A0BEE3}" type="datetimeFigureOut">
               <a:rPr lang="zh-CN" altLang="en-US" smtClean="0"/>
-              <a:t>2023/6/28</a:t>
+              <a:t>2023/7/1</a:t>
             </a:fld>
             <a:endParaRPr lang="zh-CN" altLang="en-US"/>
           </a:p>
@@ -1284,7 +1284,7 @@
           <a:p>
             <a:fld id="{7F066AC1-9EBE-4FAC-AB84-7C4667A0BEE3}" type="datetimeFigureOut">
               <a:rPr lang="zh-CN" altLang="en-US" smtClean="0"/>
-              <a:t>2023/6/28</a:t>
+              <a:t>2023/7/1</a:t>
             </a:fld>
             <a:endParaRPr lang="zh-CN" altLang="en-US"/>
           </a:p>
@@ -1454,7 +1454,7 @@
           <a:p>
             <a:fld id="{7F066AC1-9EBE-4FAC-AB84-7C4667A0BEE3}" type="datetimeFigureOut">
               <a:rPr lang="zh-CN" altLang="en-US" smtClean="0"/>
-              <a:t>2023/6/28</a:t>
+              <a:t>2023/7/1</a:t>
             </a:fld>
             <a:endParaRPr lang="zh-CN" altLang="en-US"/>
           </a:p>
@@ -1698,7 +1698,7 @@
           <a:p>
             <a:fld id="{7F066AC1-9EBE-4FAC-AB84-7C4667A0BEE3}" type="datetimeFigureOut">
               <a:rPr lang="zh-CN" altLang="en-US" smtClean="0"/>
-              <a:t>2023/6/28</a:t>
+              <a:t>2023/7/1</a:t>
             </a:fld>
             <a:endParaRPr lang="zh-CN" altLang="en-US"/>
           </a:p>
@@ -1930,7 +1930,7 @@
           <a:p>
             <a:fld id="{7F066AC1-9EBE-4FAC-AB84-7C4667A0BEE3}" type="datetimeFigureOut">
               <a:rPr lang="zh-CN" altLang="en-US" smtClean="0"/>
-              <a:t>2023/6/28</a:t>
+              <a:t>2023/7/1</a:t>
             </a:fld>
             <a:endParaRPr lang="zh-CN" altLang="en-US"/>
           </a:p>
@@ -2297,7 +2297,7 @@
           <a:p>
             <a:fld id="{7F066AC1-9EBE-4FAC-AB84-7C4667A0BEE3}" type="datetimeFigureOut">
               <a:rPr lang="zh-CN" altLang="en-US" smtClean="0"/>
-              <a:t>2023/6/28</a:t>
+              <a:t>2023/7/1</a:t>
             </a:fld>
             <a:endParaRPr lang="zh-CN" altLang="en-US"/>
           </a:p>
@@ -2415,7 +2415,7 @@
           <a:p>
             <a:fld id="{7F066AC1-9EBE-4FAC-AB84-7C4667A0BEE3}" type="datetimeFigureOut">
               <a:rPr lang="zh-CN" altLang="en-US" smtClean="0"/>
-              <a:t>2023/6/28</a:t>
+              <a:t>2023/7/1</a:t>
             </a:fld>
             <a:endParaRPr lang="zh-CN" altLang="en-US"/>
           </a:p>
@@ -2510,7 +2510,7 @@
           <a:p>
             <a:fld id="{7F066AC1-9EBE-4FAC-AB84-7C4667A0BEE3}" type="datetimeFigureOut">
               <a:rPr lang="zh-CN" altLang="en-US" smtClean="0"/>
-              <a:t>2023/6/28</a:t>
+              <a:t>2023/7/1</a:t>
             </a:fld>
             <a:endParaRPr lang="zh-CN" altLang="en-US"/>
           </a:p>
@@ -2787,7 +2787,7 @@
           <a:p>
             <a:fld id="{7F066AC1-9EBE-4FAC-AB84-7C4667A0BEE3}" type="datetimeFigureOut">
               <a:rPr lang="zh-CN" altLang="en-US" smtClean="0"/>
-              <a:t>2023/6/28</a:t>
+              <a:t>2023/7/1</a:t>
             </a:fld>
             <a:endParaRPr lang="zh-CN" altLang="en-US"/>
           </a:p>
@@ -3044,7 +3044,7 @@
           <a:p>
             <a:fld id="{7F066AC1-9EBE-4FAC-AB84-7C4667A0BEE3}" type="datetimeFigureOut">
               <a:rPr lang="zh-CN" altLang="en-US" smtClean="0"/>
-              <a:t>2023/6/28</a:t>
+              <a:t>2023/7/1</a:t>
             </a:fld>
             <a:endParaRPr lang="zh-CN" altLang="en-US"/>
           </a:p>
@@ -3257,7 +3257,7 @@
           <a:p>
             <a:fld id="{7F066AC1-9EBE-4FAC-AB84-7C4667A0BEE3}" type="datetimeFigureOut">
               <a:rPr lang="zh-CN" altLang="en-US" smtClean="0"/>
-              <a:t>2023/6/28</a:t>
+              <a:t>2023/7/1</a:t>
             </a:fld>
             <a:endParaRPr lang="zh-CN" altLang="en-US"/>
           </a:p>
@@ -4071,8 +4071,8 @@
         </p:nvSpPr>
         <p:spPr>
           <a:xfrm>
-            <a:off x="4385530" y="3091543"/>
-            <a:ext cx="2813783" cy="461665"/>
+            <a:off x="5042477" y="3029988"/>
+            <a:ext cx="2057400" cy="523220"/>
           </a:xfrm>
           <a:prstGeom prst="rect">
             <a:avLst/>
@@ -4086,26 +4086,21 @@
           <a:lstStyle/>
           <a:p>
             <a:r>
-              <a:rPr lang="en-US" altLang="zh-CN" sz="2400" dirty="0">
+              <a:rPr lang="en-US" altLang="zh-CN" sz="2800" dirty="0">
                 <a:latin typeface="楷体" panose="02010609060101010101" pitchFamily="49" charset="-122"/>
                 <a:ea typeface="楷体" panose="02010609060101010101" pitchFamily="49" charset="-122"/>
                 <a:cs typeface="Times New Roman" panose="02020603050405020304" pitchFamily="18" charset="0"/>
               </a:rPr>
-              <a:t>2022</a:t>
-            </a:r>
-            <a:r>
-              <a:rPr lang="zh-CN" altLang="en-US" sz="2400">
+              <a:t>2023</a:t>
+            </a:r>
+            <a:r>
+              <a:rPr lang="zh-CN" altLang="en-US" sz="2800" dirty="0">
                 <a:latin typeface="楷体" panose="02010609060101010101" pitchFamily="49" charset="-122"/>
                 <a:ea typeface="楷体" panose="02010609060101010101" pitchFamily="49" charset="-122"/>
                 <a:cs typeface="Times New Roman" panose="02020603050405020304" pitchFamily="18" charset="0"/>
               </a:rPr>
-              <a:t>年九月第一期</a:t>
-            </a:r>
-            <a:endParaRPr lang="zh-CN" altLang="en-US" sz="2400" dirty="0">
-              <a:latin typeface="楷体" panose="02010609060101010101" pitchFamily="49" charset="-122"/>
-              <a:ea typeface="楷体" panose="02010609060101010101" pitchFamily="49" charset="-122"/>
-              <a:cs typeface="Times New Roman" panose="02020603050405020304" pitchFamily="18" charset="0"/>
-            </a:endParaRPr>
+              <a:t>年精选</a:t>
+            </a:r>
           </a:p>
         </p:txBody>
       </p:sp>

</xml_diff>

<commit_message>
Site updated: 2023-07-26 23:29:13
</commit_message>
<xml_diff>
--- a/demo/sarcasm/jiaoben2304/first_page.pptx
+++ b/demo/sarcasm/jiaoben2304/first_page.pptx
@@ -200,7 +200,7 @@
           <a:p>
             <a:fld id="{9F2C887D-13CF-45CF-8BA1-CEA69189E219}" type="datetimeFigureOut">
               <a:rPr lang="zh-CN" altLang="en-US" smtClean="0"/>
-              <a:t>2023/7/1</a:t>
+              <a:t>2023/7/19</a:t>
             </a:fld>
             <a:endParaRPr lang="zh-CN" altLang="en-US"/>
           </a:p>
@@ -934,7 +934,7 @@
           <a:p>
             <a:fld id="{7F066AC1-9EBE-4FAC-AB84-7C4667A0BEE3}" type="datetimeFigureOut">
               <a:rPr lang="zh-CN" altLang="en-US" smtClean="0"/>
-              <a:t>2023/7/1</a:t>
+              <a:t>2023/7/19</a:t>
             </a:fld>
             <a:endParaRPr lang="zh-CN" altLang="en-US"/>
           </a:p>
@@ -1104,7 +1104,7 @@
           <a:p>
             <a:fld id="{7F066AC1-9EBE-4FAC-AB84-7C4667A0BEE3}" type="datetimeFigureOut">
               <a:rPr lang="zh-CN" altLang="en-US" smtClean="0"/>
-              <a:t>2023/7/1</a:t>
+              <a:t>2023/7/19</a:t>
             </a:fld>
             <a:endParaRPr lang="zh-CN" altLang="en-US"/>
           </a:p>
@@ -1284,7 +1284,7 @@
           <a:p>
             <a:fld id="{7F066AC1-9EBE-4FAC-AB84-7C4667A0BEE3}" type="datetimeFigureOut">
               <a:rPr lang="zh-CN" altLang="en-US" smtClean="0"/>
-              <a:t>2023/7/1</a:t>
+              <a:t>2023/7/19</a:t>
             </a:fld>
             <a:endParaRPr lang="zh-CN" altLang="en-US"/>
           </a:p>
@@ -1454,7 +1454,7 @@
           <a:p>
             <a:fld id="{7F066AC1-9EBE-4FAC-AB84-7C4667A0BEE3}" type="datetimeFigureOut">
               <a:rPr lang="zh-CN" altLang="en-US" smtClean="0"/>
-              <a:t>2023/7/1</a:t>
+              <a:t>2023/7/19</a:t>
             </a:fld>
             <a:endParaRPr lang="zh-CN" altLang="en-US"/>
           </a:p>
@@ -1698,7 +1698,7 @@
           <a:p>
             <a:fld id="{7F066AC1-9EBE-4FAC-AB84-7C4667A0BEE3}" type="datetimeFigureOut">
               <a:rPr lang="zh-CN" altLang="en-US" smtClean="0"/>
-              <a:t>2023/7/1</a:t>
+              <a:t>2023/7/19</a:t>
             </a:fld>
             <a:endParaRPr lang="zh-CN" altLang="en-US"/>
           </a:p>
@@ -1930,7 +1930,7 @@
           <a:p>
             <a:fld id="{7F066AC1-9EBE-4FAC-AB84-7C4667A0BEE3}" type="datetimeFigureOut">
               <a:rPr lang="zh-CN" altLang="en-US" smtClean="0"/>
-              <a:t>2023/7/1</a:t>
+              <a:t>2023/7/19</a:t>
             </a:fld>
             <a:endParaRPr lang="zh-CN" altLang="en-US"/>
           </a:p>
@@ -2297,7 +2297,7 @@
           <a:p>
             <a:fld id="{7F066AC1-9EBE-4FAC-AB84-7C4667A0BEE3}" type="datetimeFigureOut">
               <a:rPr lang="zh-CN" altLang="en-US" smtClean="0"/>
-              <a:t>2023/7/1</a:t>
+              <a:t>2023/7/19</a:t>
             </a:fld>
             <a:endParaRPr lang="zh-CN" altLang="en-US"/>
           </a:p>
@@ -2415,7 +2415,7 @@
           <a:p>
             <a:fld id="{7F066AC1-9EBE-4FAC-AB84-7C4667A0BEE3}" type="datetimeFigureOut">
               <a:rPr lang="zh-CN" altLang="en-US" smtClean="0"/>
-              <a:t>2023/7/1</a:t>
+              <a:t>2023/7/19</a:t>
             </a:fld>
             <a:endParaRPr lang="zh-CN" altLang="en-US"/>
           </a:p>
@@ -2510,7 +2510,7 @@
           <a:p>
             <a:fld id="{7F066AC1-9EBE-4FAC-AB84-7C4667A0BEE3}" type="datetimeFigureOut">
               <a:rPr lang="zh-CN" altLang="en-US" smtClean="0"/>
-              <a:t>2023/7/1</a:t>
+              <a:t>2023/7/19</a:t>
             </a:fld>
             <a:endParaRPr lang="zh-CN" altLang="en-US"/>
           </a:p>
@@ -2787,7 +2787,7 @@
           <a:p>
             <a:fld id="{7F066AC1-9EBE-4FAC-AB84-7C4667A0BEE3}" type="datetimeFigureOut">
               <a:rPr lang="zh-CN" altLang="en-US" smtClean="0"/>
-              <a:t>2023/7/1</a:t>
+              <a:t>2023/7/19</a:t>
             </a:fld>
             <a:endParaRPr lang="zh-CN" altLang="en-US"/>
           </a:p>
@@ -3044,7 +3044,7 @@
           <a:p>
             <a:fld id="{7F066AC1-9EBE-4FAC-AB84-7C4667A0BEE3}" type="datetimeFigureOut">
               <a:rPr lang="zh-CN" altLang="en-US" smtClean="0"/>
-              <a:t>2023/7/1</a:t>
+              <a:t>2023/7/19</a:t>
             </a:fld>
             <a:endParaRPr lang="zh-CN" altLang="en-US"/>
           </a:p>
@@ -3257,7 +3257,7 @@
           <a:p>
             <a:fld id="{7F066AC1-9EBE-4FAC-AB84-7C4667A0BEE3}" type="datetimeFigureOut">
               <a:rPr lang="zh-CN" altLang="en-US" smtClean="0"/>
-              <a:t>2023/7/1</a:t>
+              <a:t>2023/7/19</a:t>
             </a:fld>
             <a:endParaRPr lang="zh-CN" altLang="en-US"/>
           </a:p>
@@ -4071,8 +4071,8 @@
         </p:nvSpPr>
         <p:spPr>
           <a:xfrm>
-            <a:off x="5042477" y="3029988"/>
-            <a:ext cx="2057400" cy="523220"/>
+            <a:off x="4049486" y="3029988"/>
+            <a:ext cx="3050391" cy="461665"/>
           </a:xfrm>
           <a:prstGeom prst="rect">
             <a:avLst/>
@@ -4086,20 +4086,20 @@
           <a:lstStyle/>
           <a:p>
             <a:r>
-              <a:rPr lang="en-US" altLang="zh-CN" sz="2800" dirty="0">
+              <a:rPr lang="en-US" altLang="zh-CN" sz="2400" dirty="0">
                 <a:latin typeface="楷体" panose="02010609060101010101" pitchFamily="49" charset="-122"/>
                 <a:ea typeface="楷体" panose="02010609060101010101" pitchFamily="49" charset="-122"/>
                 <a:cs typeface="Times New Roman" panose="02020603050405020304" pitchFamily="18" charset="0"/>
               </a:rPr>
-              <a:t>2023</a:t>
-            </a:r>
-            <a:r>
-              <a:rPr lang="zh-CN" altLang="en-US" sz="2800" dirty="0">
+              <a:t>2022</a:t>
+            </a:r>
+            <a:r>
+              <a:rPr lang="zh-CN" altLang="en-US" sz="2400" dirty="0">
                 <a:latin typeface="楷体" panose="02010609060101010101" pitchFamily="49" charset="-122"/>
                 <a:ea typeface="楷体" panose="02010609060101010101" pitchFamily="49" charset="-122"/>
                 <a:cs typeface="Times New Roman" panose="02020603050405020304" pitchFamily="18" charset="0"/>
               </a:rPr>
-              <a:t>年精选</a:t>
+              <a:t>年十二月第二期</a:t>
             </a:r>
           </a:p>
         </p:txBody>

</xml_diff>